<commit_message>
Rebuild slide 1 from the live microphone run
Slide 1 now shows a real step on the Alamo Music SM58-LC page instead of
a books.toscrape.com step, so it matches the live demo. Adds the latest
live run and tidies truncated slide text.

Co-Authored-By: Claude Sonnet 5.5 <noreply@anthropic.com>
</commit_message>
<xml_diff>
--- a/Homework/Session 4/Browser_Agent_Price_Demo/slides/browser_agent_demo.pptx
+++ b/Homework/Session 4/Browser_Agent_Price_Demo/slides/browser_agent_demo.pptx
@@ -3725,7 +3725,7 @@
               </a:defRPr>
             </a:pPr>
             <a:r>
-              <a:t>Real step 4 from our run (openai/gpt-4.1, browser-use 0.13.11), headed Chrome, fresh profile</a:t>
+              <a:t>Real step 2 from our run (openai/gpt-4.1, browser-use 0.13.11), headed Chrome, fresh profile</a:t>
             </a:r>
           </a:p>
         </p:txBody>
@@ -3814,7 +3814,7 @@
       </p:sp>
       <p:pic>
         <p:nvPicPr>
-          <p:cNvPr id="6" name="Picture 5" descr="step_04.png"/>
+          <p:cNvPr id="6" name="Picture 5" descr="step_02.png"/>
           <p:cNvPicPr>
             <a:picLocks noChangeAspect="1"/>
           </p:cNvPicPr>
@@ -4041,7 +4041,7 @@
               </a:defRPr>
             </a:pPr>
             <a:r>
-              <a:t>Click the 'next' link at the bottom of the catalogue to go to page 2 and search for the remaining two books.</a:t>
+              <a:t>Scroll down the page to search for shipping cost information or any note about free shipping.</a:t>
             </a:r>
           </a:p>
           <a:p>
@@ -4077,7 +4077,7 @@
               </a:defRPr>
             </a:pPr>
             <a:r>
-              <a:t>I have already processed 'Sapiens: A Brief History of Humankind.' After scrolling, I do not see 'Sophie's World' or 'Reasons to Stay Alive' on the remainder of page 1. The next step is to go to page 2 using the 'next' link at the bottom and continue searching for the other two titles.</a:t>
+              <a:t>I have navigated to the product page for the Shure SM58-LC Cardioid Dynamic Vocal Microphone on alamomusic.com. The product title and SKU match the requested model (SM58-LC, new, no cable). The price is clearly shown as $109.00. I need to check the page for shipping information—whether shipping is ...</a:t>
             </a:r>
           </a:p>
         </p:txBody>
@@ -4238,7 +4238,7 @@
               </a:defRPr>
             </a:pPr>
             <a:r>
-              <a:t>Action(s): click</a:t>
+              <a:t>Action(s): scroll</a:t>
             </a:r>
           </a:p>
           <a:p>
@@ -4261,7 +4261,7 @@
               </a:defRPr>
             </a:pPr>
             <a:r>
-              <a:t>[{"click": {"index": 3762}}]</a:t>
+              <a:t>[{"scroll": {"down": true, "pages": 1.0}}]</a:t>
             </a:r>
           </a:p>
           <a:p>
@@ -4284,7 +4284,7 @@
               </a:defRPr>
             </a:pPr>
             <a:r>
-              <a:t>Step took 7.09 s, 14,380 tokens</a:t>
+              <a:t>(timing for each step is in the report)</a:t>
             </a:r>
           </a:p>
         </p:txBody>
@@ -4416,7 +4416,7 @@
       </p:sp>
       <p:pic>
         <p:nvPicPr>
-          <p:cNvPr id="19" name="Picture 18" descr="step_05.png"/>
+          <p:cNvPr id="19" name="Picture 18" descr="step_03.png"/>
           <p:cNvPicPr>
             <a:picLocks noChangeAspect="1"/>
           </p:cNvPicPr>
@@ -4482,7 +4482,7 @@
               </a:defRPr>
             </a:pPr>
             <a:r>
-              <a:t>Agent says: Successfully navigated to page 2 of the catalogue. Ready to search for the remaining books.</a:t>
+              <a:t>Agent says: Scroll action succeeded, but no explicit shipping cost or free shipping note is visible yet.</a:t>
             </a:r>
           </a:p>
         </p:txBody>

</xml_diff>